<commit_message>
fix(backend): 提取共享依赖到 dependencies.py 修复循环导入，补充 selection_behavior 注入
- 新建 dependencies.py：集中管理 manager/orchestrator/interview_agents/log_to_therapist
- main.py 及各 router 改为从 dependencies 导入，消除循环导入
- core.py generate_follow_up_questions 新增 selection_behavior 参数
- .gitignore 添加 node_modules/ package-lock.json package.json
- PPT 叙述重心调整
</commit_message>
<xml_diff>
--- a/情感图像生成_项目介绍.pptx
+++ b/情感图像生成_项目介绍.pptx
@@ -5205,7 +5205,7 @@
         <p:spPr>
           <a:xfrm>
             <a:off x="731520" y="1645920"/>
-            <a:ext cx="10698480" cy="4572000"/>
+            <a:ext cx="10698480" cy="3400931"/>
           </a:xfrm>
           <a:prstGeom prst="rect">
             <a:avLst/>
@@ -5232,8 +5232,46 @@
               </a:defRPr>
             </a:pPr>
             <a:r>
-              <a:t>●  完整的端到端系统：从绘画采集 → 多模态分析 → 自主访谈 → 情感图像生成 → 艺术反馈报告</a:t>
-            </a:r>
+              <a:rPr dirty="0"/>
+              <a:t>●  </a:t>
+            </a:r>
+            <a:r>
+              <a:rPr dirty="0" err="1"/>
+              <a:t>完整的端到端系统：从绘画采集</a:t>
+            </a:r>
+            <a:r>
+              <a:rPr dirty="0"/>
+              <a:t> → </a:t>
+            </a:r>
+            <a:r>
+              <a:rPr dirty="0" err="1"/>
+              <a:t>多模态分析</a:t>
+            </a:r>
+            <a:r>
+              <a:rPr dirty="0"/>
+              <a:t> → </a:t>
+            </a:r>
+            <a:r>
+              <a:rPr dirty="0" err="1"/>
+              <a:t>自主访谈</a:t>
+            </a:r>
+            <a:r>
+              <a:rPr dirty="0"/>
+              <a:t> → </a:t>
+            </a:r>
+            <a:r>
+              <a:rPr dirty="0" err="1"/>
+              <a:t>情感图像生成</a:t>
+            </a:r>
+            <a:r>
+              <a:rPr dirty="0"/>
+              <a:t> → </a:t>
+            </a:r>
+            <a:r>
+              <a:rPr dirty="0" err="1"/>
+              <a:t>艺术反馈报告</a:t>
+            </a:r>
+            <a:endParaRPr dirty="0"/>
           </a:p>
           <a:p>
             <a:pPr>
@@ -5250,8 +5288,14 @@
               </a:defRPr>
             </a:pPr>
             <a:r>
-              <a:t>●  双模型安全架构落地：本地Qwen3.5 VLM + 云端Kimi-K2.5 LLM，原始敏感数据零上云</a:t>
-            </a:r>
+              <a:rPr dirty="0"/>
+              <a:t>●  双模型安全架构落地：本地Qwen3.5 VLM + 云端Kimi-K2.5 </a:t>
+            </a:r>
+            <a:r>
+              <a:rPr dirty="0" err="1"/>
+              <a:t>LLM，原始敏感数据零上云</a:t>
+            </a:r>
+            <a:endParaRPr dirty="0"/>
           </a:p>
           <a:p>
             <a:pPr>
@@ -5268,6 +5312,7 @@
               </a:defRPr>
             </a:pPr>
             <a:r>
+              <a:rPr dirty="0"/>
               <a:t>●  100%结构化输出保障：lm-format-enforcer约束解码，彻底消除JSON格式崩坏</a:t>
             </a:r>
           </a:p>
@@ -5286,7 +5331,16 @@
               </a:defRPr>
             </a:pPr>
             <a:r>
-              <a:t>●  端侧推理优化：RTX 5060 8GB笔记本GPU即可流畅运行VLM分析+FLUX.2图像生成</a:t>
+              <a:rPr dirty="0"/>
+              <a:t>●  </a:t>
+            </a:r>
+            <a:r>
+              <a:rPr dirty="0" err="1"/>
+              <a:t>端侧推理优化：RTX</a:t>
+            </a:r>
+            <a:r>
+              <a:rPr dirty="0"/>
+              <a:t> 5060 8GB笔记本GPU即可流畅运行VLM分析+FLUX.2图像生成</a:t>
             </a:r>
           </a:p>
           <a:p>
@@ -5304,8 +5358,22 @@
               </a:defRPr>
             </a:pPr>
             <a:r>
-              <a:t>●  Agent架构重构完成：Tool Registry + Plan Engine + Orchestrator，支持失败恢复与状态持久化</a:t>
-            </a:r>
+              <a:rPr dirty="0"/>
+              <a:t>●  </a:t>
+            </a:r>
+            <a:r>
+              <a:rPr dirty="0" err="1"/>
+              <a:t>Agent架构重构完成：Tool</a:t>
+            </a:r>
+            <a:r>
+              <a:rPr dirty="0"/>
+              <a:t> Registry + Plan Engine + </a:t>
+            </a:r>
+            <a:r>
+              <a:rPr dirty="0" err="1"/>
+              <a:t>Orchestrator，支持失败恢复与状态持久化</a:t>
+            </a:r>
+            <a:endParaRPr dirty="0"/>
           </a:p>
           <a:p>
             <a:pPr>
@@ -5322,7 +5390,16 @@
               </a:defRPr>
             </a:pPr>
             <a:r>
-              <a:t>●  伦理合规整改完成：系统从「临床诊断工具」成功转型为「情绪表达艺术伙伴」</a:t>
+              <a:rPr dirty="0"/>
+              <a:t>●  </a:t>
+            </a:r>
+            <a:r>
+              <a:rPr dirty="0" err="1"/>
+              <a:t>伦理合规整改完成：系统从「临床诊断工具」成功转型为「情绪表达艺术伙伴</a:t>
+            </a:r>
+            <a:r>
+              <a:rPr dirty="0"/>
+              <a:t>」</a:t>
             </a:r>
           </a:p>
         </p:txBody>
@@ -5504,6 +5581,7 @@
                 </a:solidFill>
               </a:defRPr>
             </a:pPr>
+            <a:endParaRPr/>
           </a:p>
           <a:p>
             <a:pPr>
@@ -5626,6 +5704,7 @@
                 </a:solidFill>
               </a:defRPr>
             </a:pPr>
+            <a:endParaRPr/>
           </a:p>
           <a:p>
             <a:pPr>
@@ -6920,7 +6999,7 @@
           <a:lstStyle/>
           <a:p>
             <a:pPr>
-              <a:defRPr sz="1600" i="1" b="1">
+              <a:defRPr sz="1600" b="1" i="1">
                 <a:solidFill>
                   <a:srgbClr val="5A6A7A"/>
                 </a:solidFill>

</xml_diff>